<commit_message>
Fix title slide layout in published decks
</commit_message>
<xml_diff>
--- a/第10回_RAG/excel_rag_slides.pptx
+++ b/第10回_RAG/excel_rag_slides.pptx
@@ -3210,7 +3210,7 @@
         <p:spPr>
           <a:xfrm>
             <a:off x="640080" y="868680"/>
-            <a:ext cx="6949440" cy="566928"/>
+            <a:ext cx="6949440" cy="594360"/>
           </a:xfrm>
           <a:prstGeom prst="rect">
             <a:avLst/>
@@ -3227,11 +3227,11 @@
             <a:r>
               <a:rPr sz="2500" b="1">
                 <a:solidFill>
-                  <a:srgbClr val="1F2A44"/>
-                </a:solidFill>
-                <a:latin typeface="Yu Gothic"/>
-              </a:rPr>
-              <a:t>Excelで体験する言語モデルのしくみ</a:t>
+                  <a:srgbClr val="24324B"/>
+                </a:solidFill>
+                <a:latin typeface="Yu Gothic"/>
+              </a:rPr>
+              <a:t>Excelで体験する 言語モデルのしくみ</a:t>
             </a:r>
           </a:p>
         </p:txBody>
@@ -3297,7 +3297,7 @@
             <a:r>
               <a:rPr sz="1500" b="0">
                 <a:solidFill>
-                  <a:srgbClr val="526279"/>
+                  <a:srgbClr val="475569"/>
                 </a:solidFill>
                 <a:latin typeface="Yu Gothic"/>
               </a:rPr>

</xml_diff>